<commit_message>
Summary slides, troubleshooting 3
- Introduction slides

- Map construction slides

- Troubleshooting example 3
</commit_message>
<xml_diff>
--- a/slides/04_antibody_landscapes.pptx
+++ b/slides/04_antibody_landscapes.pptx
@@ -16,9 +16,9 @@
     <p:sldId id="262" r:id="rId7"/>
     <p:sldId id="263" r:id="rId8"/>
     <p:sldId id="264" r:id="rId9"/>
-    <p:sldId id="265" r:id="rId10"/>
-    <p:sldId id="266" r:id="rId11"/>
-    <p:sldId id="267" r:id="rId12"/>
+    <p:sldId id="267" r:id="rId10"/>
+    <p:sldId id="265" r:id="rId11"/>
+    <p:sldId id="266" r:id="rId12"/>
   </p:sldIdLst>
   <p:sldSz cx="12192000" cy="6858000"/>
   <p:notesSz cx="6858000" cy="9144000"/>
@@ -117,6 +117,11 @@
       </a:defRPr>
     </a:lvl9pPr>
   </p:defaultTextStyle>
+  <p:extLst>
+    <p:ext uri="{EFAFB233-063F-42B5-8137-9DF3F51BA10A}">
+      <p15:sldGuideLst xmlns:p15="http://schemas.microsoft.com/office/powerpoint/2012/main"/>
+    </p:ext>
+  </p:extLst>
 </p:presentation>
 </file>
 
@@ -202,7 +207,7 @@
           <a:p>
             <a:fld id="{48748626-7256-3046-8BAF-BE879F74980C}" type="datetimeFigureOut">
               <a:rPr lang="en-US" smtClean="0"/>
-              <a:t>6/25/25</a:t>
+              <a:t>6/30/25</a:t>
             </a:fld>
             <a:endParaRPr lang="en-US"/>
           </a:p>
@@ -619,7 +624,7 @@
           <a:p>
             <a:fld id="{8F6CD2E1-1F8E-5347-86A6-EFE8BDCF2FF8}" type="datetimeFigureOut">
               <a:rPr lang="en-US" smtClean="0"/>
-              <a:t>6/25/25</a:t>
+              <a:t>6/30/25</a:t>
             </a:fld>
             <a:endParaRPr lang="en-US"/>
           </a:p>
@@ -819,7 +824,7 @@
           <a:p>
             <a:fld id="{8F6CD2E1-1F8E-5347-86A6-EFE8BDCF2FF8}" type="datetimeFigureOut">
               <a:rPr lang="en-US" smtClean="0"/>
-              <a:t>6/25/25</a:t>
+              <a:t>6/30/25</a:t>
             </a:fld>
             <a:endParaRPr lang="en-US"/>
           </a:p>
@@ -1029,7 +1034,7 @@
           <a:p>
             <a:fld id="{8F6CD2E1-1F8E-5347-86A6-EFE8BDCF2FF8}" type="datetimeFigureOut">
               <a:rPr lang="en-US" smtClean="0"/>
-              <a:t>6/25/25</a:t>
+              <a:t>6/30/25</a:t>
             </a:fld>
             <a:endParaRPr lang="en-US"/>
           </a:p>
@@ -1229,7 +1234,7 @@
           <a:p>
             <a:fld id="{8F6CD2E1-1F8E-5347-86A6-EFE8BDCF2FF8}" type="datetimeFigureOut">
               <a:rPr lang="en-US" smtClean="0"/>
-              <a:t>6/25/25</a:t>
+              <a:t>6/30/25</a:t>
             </a:fld>
             <a:endParaRPr lang="en-US"/>
           </a:p>
@@ -1505,7 +1510,7 @@
           <a:p>
             <a:fld id="{8F6CD2E1-1F8E-5347-86A6-EFE8BDCF2FF8}" type="datetimeFigureOut">
               <a:rPr lang="en-US" smtClean="0"/>
-              <a:t>6/25/25</a:t>
+              <a:t>6/30/25</a:t>
             </a:fld>
             <a:endParaRPr lang="en-US"/>
           </a:p>
@@ -1773,7 +1778,7 @@
           <a:p>
             <a:fld id="{8F6CD2E1-1F8E-5347-86A6-EFE8BDCF2FF8}" type="datetimeFigureOut">
               <a:rPr lang="en-US" smtClean="0"/>
-              <a:t>6/25/25</a:t>
+              <a:t>6/30/25</a:t>
             </a:fld>
             <a:endParaRPr lang="en-US"/>
           </a:p>
@@ -2188,7 +2193,7 @@
           <a:p>
             <a:fld id="{8F6CD2E1-1F8E-5347-86A6-EFE8BDCF2FF8}" type="datetimeFigureOut">
               <a:rPr lang="en-US" smtClean="0"/>
-              <a:t>6/25/25</a:t>
+              <a:t>6/30/25</a:t>
             </a:fld>
             <a:endParaRPr lang="en-US"/>
           </a:p>
@@ -2330,7 +2335,7 @@
           <a:p>
             <a:fld id="{8F6CD2E1-1F8E-5347-86A6-EFE8BDCF2FF8}" type="datetimeFigureOut">
               <a:rPr lang="en-US" smtClean="0"/>
-              <a:t>6/25/25</a:t>
+              <a:t>6/30/25</a:t>
             </a:fld>
             <a:endParaRPr lang="en-US"/>
           </a:p>
@@ -2443,7 +2448,7 @@
           <a:p>
             <a:fld id="{8F6CD2E1-1F8E-5347-86A6-EFE8BDCF2FF8}" type="datetimeFigureOut">
               <a:rPr lang="en-US" smtClean="0"/>
-              <a:t>6/25/25</a:t>
+              <a:t>6/30/25</a:t>
             </a:fld>
             <a:endParaRPr lang="en-US"/>
           </a:p>
@@ -2756,7 +2761,7 @@
           <a:p>
             <a:fld id="{8F6CD2E1-1F8E-5347-86A6-EFE8BDCF2FF8}" type="datetimeFigureOut">
               <a:rPr lang="en-US" smtClean="0"/>
-              <a:t>6/25/25</a:t>
+              <a:t>6/30/25</a:t>
             </a:fld>
             <a:endParaRPr lang="en-US"/>
           </a:p>
@@ -3045,7 +3050,7 @@
           <a:p>
             <a:fld id="{8F6CD2E1-1F8E-5347-86A6-EFE8BDCF2FF8}" type="datetimeFigureOut">
               <a:rPr lang="en-US" smtClean="0"/>
-              <a:t>6/25/25</a:t>
+              <a:t>6/30/25</a:t>
             </a:fld>
             <a:endParaRPr lang="en-US"/>
           </a:p>
@@ -3288,7 +3293,7 @@
           <a:p>
             <a:fld id="{8F6CD2E1-1F8E-5347-86A6-EFE8BDCF2FF8}" type="datetimeFigureOut">
               <a:rPr lang="en-US" smtClean="0"/>
-              <a:t>6/25/25</a:t>
+              <a:t>6/30/25</a:t>
             </a:fld>
             <a:endParaRPr lang="en-US"/>
           </a:p>
@@ -3809,7 +3814,7 @@
           <p:cNvPr id="2" name="Title 1">
             <a:extLst>
               <a:ext uri="{FF2B5EF4-FFF2-40B4-BE49-F238E27FC236}">
-                <a16:creationId xmlns:a16="http://schemas.microsoft.com/office/drawing/2014/main" id="{69664FC9-5CAD-F2F9-1DC8-1E67AD2A44E9}"/>
+                <a16:creationId xmlns:a16="http://schemas.microsoft.com/office/drawing/2014/main" id="{4A407B3B-EE72-821F-0B1D-D3BA65D4AD2B}"/>
               </a:ext>
             </a:extLst>
           </p:cNvPr>
@@ -3827,377 +3832,139 @@
           <a:p>
             <a:r>
               <a:rPr lang="en-US" dirty="0"/>
-              <a:t>LO(W)ESS</a:t>
-            </a:r>
-          </a:p>
-        </p:txBody>
-      </p:sp>
-      <p:sp>
-        <p:nvSpPr>
-          <p:cNvPr id="5" name="TextBox 4">
-            <a:extLst>
-              <a:ext uri="{FF2B5EF4-FFF2-40B4-BE49-F238E27FC236}">
-                <a16:creationId xmlns:a16="http://schemas.microsoft.com/office/drawing/2014/main" id="{0D4A0B6B-F182-FB9F-8FBC-A44EB4EEE43D}"/>
-              </a:ext>
-            </a:extLst>
-          </p:cNvPr>
-          <p:cNvSpPr txBox="1"/>
+              <a:t>LO(W)ESS fit: locally (weighted) estimated scatterplot smoothing</a:t>
+            </a:r>
+          </a:p>
+        </p:txBody>
+      </p:sp>
+      <p:sp>
+        <p:nvSpPr>
+          <p:cNvPr id="3" name="Content Placeholder 2">
+            <a:extLst>
+              <a:ext uri="{FF2B5EF4-FFF2-40B4-BE49-F238E27FC236}">
+                <a16:creationId xmlns:a16="http://schemas.microsoft.com/office/drawing/2014/main" id="{A99A207F-16B7-76FF-FFF2-A1BB641A751A}"/>
+              </a:ext>
+            </a:extLst>
+          </p:cNvPr>
+          <p:cNvSpPr>
+            <a:spLocks noGrp="1"/>
+          </p:cNvSpPr>
+          <p:nvPr>
+            <p:ph idx="1"/>
+          </p:nvPr>
+        </p:nvSpPr>
+        <p:spPr/>
+        <p:txBody>
+          <a:bodyPr/>
+          <a:lstStyle/>
+          <a:p>
+            <a:r>
+              <a:rPr lang="en-US" dirty="0"/>
+              <a:t>Immunity distributes across antigenic space in hills and valleys</a:t>
+            </a:r>
+          </a:p>
+        </p:txBody>
+      </p:sp>
+      <p:pic>
+        <p:nvPicPr>
+          <p:cNvPr id="5122" name="Picture 2">
+            <a:extLst>
+              <a:ext uri="{FF2B5EF4-FFF2-40B4-BE49-F238E27FC236}">
+                <a16:creationId xmlns:a16="http://schemas.microsoft.com/office/drawing/2014/main" id="{AAF3FCE3-9A3C-C3EB-14B8-F2E7BAFED45D}"/>
+              </a:ext>
+            </a:extLst>
+          </p:cNvPr>
+          <p:cNvPicPr>
+            <a:picLocks noChangeAspect="1" noChangeArrowheads="1"/>
+          </p:cNvPicPr>
           <p:nvPr/>
-        </p:nvSpPr>
-        <p:spPr>
+        </p:nvPicPr>
+        <p:blipFill rotWithShape="1">
+          <a:blip r:embed="rId2">
+            <a:extLst>
+              <a:ext uri="{28A0092B-C50C-407E-A947-70E740481C1C}">
+                <a14:useLocalDpi xmlns:a14="http://schemas.microsoft.com/office/drawing/2010/main" val="0"/>
+              </a:ext>
+            </a:extLst>
+          </a:blip>
+          <a:srcRect b="49683"/>
+          <a:stretch>
+            <a:fillRect/>
+          </a:stretch>
+        </p:blipFill>
+        <p:spPr bwMode="auto">
           <a:xfrm>
-            <a:off x="483198" y="2119257"/>
-            <a:ext cx="4250168" cy="3139321"/>
+            <a:off x="1306710" y="2726175"/>
+            <a:ext cx="4500563" cy="3450788"/>
           </a:xfrm>
           <a:prstGeom prst="rect">
             <a:avLst/>
           </a:prstGeom>
           <a:noFill/>
-        </p:spPr>
-        <p:txBody>
-          <a:bodyPr wrap="square" rtlCol="0">
-            <a:spAutoFit/>
-          </a:bodyPr>
-          <a:lstStyle/>
-          <a:p>
-            <a:r>
-              <a:rPr lang="en-US" dirty="0"/>
-              <a:t>Fit local polynomial regression</a:t>
-            </a:r>
-          </a:p>
-          <a:p>
-            <a:endParaRPr lang="en-US" dirty="0"/>
-          </a:p>
-          <a:p>
-            <a:r>
-              <a:rPr lang="en-US" dirty="0"/>
-              <a:t>Degree of polynomial (here 1)</a:t>
-            </a:r>
-          </a:p>
-          <a:p>
-            <a:endParaRPr lang="en-US" dirty="0"/>
-          </a:p>
-          <a:p>
-            <a:r>
-              <a:rPr lang="en-US" dirty="0"/>
-              <a:t>Span (bandwidth) = How many points to include in local regression, often fraction of data points</a:t>
-            </a:r>
-            <a:br>
-              <a:rPr lang="en-US" dirty="0"/>
-            </a:br>
-            <a:r>
-              <a:rPr lang="en-US" dirty="0"/>
-              <a:t>(larger span </a:t>
-            </a:r>
-            <a:r>
-              <a:rPr lang="en-US" dirty="0">
-                <a:sym typeface="Wingdings" pitchFamily="2" charset="2"/>
-              </a:rPr>
-              <a:t> more points included)</a:t>
-            </a:r>
-          </a:p>
-          <a:p>
-            <a:endParaRPr lang="en-US" dirty="0">
-              <a:sym typeface="Wingdings" pitchFamily="2" charset="2"/>
-            </a:endParaRPr>
-          </a:p>
-          <a:p>
-            <a:r>
-              <a:rPr lang="en-US" dirty="0">
-                <a:sym typeface="Wingdings" pitchFamily="2" charset="2"/>
-              </a:rPr>
-              <a:t>Points in the center are weighted more</a:t>
-            </a:r>
-            <a:endParaRPr lang="en-US" dirty="0"/>
-          </a:p>
-          <a:p>
-            <a:endParaRPr lang="en-US" dirty="0"/>
-          </a:p>
-        </p:txBody>
-      </p:sp>
+          <a:extLst>
+            <a:ext uri="{909E8E84-426E-40DD-AFC4-6F175D3DCCD1}">
+              <a14:hiddenFill xmlns:a14="http://schemas.microsoft.com/office/drawing/2010/main">
+                <a:solidFill>
+                  <a:srgbClr val="FFFFFF"/>
+                </a:solidFill>
+              </a14:hiddenFill>
+            </a:ext>
+          </a:extLst>
+        </p:spPr>
+      </p:pic>
       <p:pic>
         <p:nvPicPr>
-          <p:cNvPr id="7" name="Picture 6">
-            <a:extLst>
-              <a:ext uri="{FF2B5EF4-FFF2-40B4-BE49-F238E27FC236}">
-                <a16:creationId xmlns:a16="http://schemas.microsoft.com/office/drawing/2014/main" id="{89DABC51-F894-890C-087F-3503984F22D2}"/>
+          <p:cNvPr id="4" name="Picture 2">
+            <a:extLst>
+              <a:ext uri="{FF2B5EF4-FFF2-40B4-BE49-F238E27FC236}">
+                <a16:creationId xmlns:a16="http://schemas.microsoft.com/office/drawing/2014/main" id="{E2263491-3294-09B3-1085-03EB336FB7BD}"/>
               </a:ext>
             </a:extLst>
           </p:cNvPr>
           <p:cNvPicPr>
-            <a:picLocks noChangeAspect="1"/>
+            <a:picLocks noChangeAspect="1" noChangeArrowheads="1"/>
           </p:cNvPicPr>
           <p:nvPr/>
         </p:nvPicPr>
-        <p:blipFill>
-          <a:blip r:embed="rId2"/>
+        <p:blipFill rotWithShape="1">
+          <a:blip r:embed="rId2">
+            <a:extLst>
+              <a:ext uri="{28A0092B-C50C-407E-A947-70E740481C1C}">
+                <a14:useLocalDpi xmlns:a14="http://schemas.microsoft.com/office/drawing/2010/main" val="0"/>
+              </a:ext>
+            </a:extLst>
+          </a:blip>
+          <a:srcRect t="49683"/>
           <a:stretch>
             <a:fillRect/>
           </a:stretch>
         </p:blipFill>
-        <p:spPr>
+        <p:spPr bwMode="auto">
           <a:xfrm>
-            <a:off x="4787302" y="527050"/>
-            <a:ext cx="6921500" cy="5803900"/>
-          </a:xfrm>
-          <a:prstGeom prst="rect">
-            <a:avLst/>
-          </a:prstGeom>
-        </p:spPr>
-      </p:pic>
-      <p:cxnSp>
-        <p:nvCxnSpPr>
-          <p:cNvPr id="9" name="Straight Connector 8">
-            <a:extLst>
-              <a:ext uri="{FF2B5EF4-FFF2-40B4-BE49-F238E27FC236}">
-                <a16:creationId xmlns:a16="http://schemas.microsoft.com/office/drawing/2014/main" id="{75578EF3-FC25-BCBA-64BF-503F32937C40}"/>
-              </a:ext>
-            </a:extLst>
-          </p:cNvPr>
-          <p:cNvCxnSpPr/>
-          <p:nvPr/>
-        </p:nvCxnSpPr>
-        <p:spPr>
-          <a:xfrm>
-            <a:off x="5948979" y="4873214"/>
-            <a:ext cx="5099125" cy="0"/>
-          </a:xfrm>
-          <a:prstGeom prst="line">
-            <a:avLst/>
-          </a:prstGeom>
-          <a:ln>
-            <a:solidFill>
-              <a:schemeClr val="tx2">
-                <a:lumMod val="50000"/>
-                <a:lumOff val="50000"/>
-              </a:schemeClr>
-            </a:solidFill>
-          </a:ln>
-        </p:spPr>
-        <p:style>
-          <a:lnRef idx="2">
-            <a:schemeClr val="accent1"/>
-          </a:lnRef>
-          <a:fillRef idx="0">
-            <a:schemeClr val="accent1"/>
-          </a:fillRef>
-          <a:effectRef idx="1">
-            <a:schemeClr val="accent1"/>
-          </a:effectRef>
-          <a:fontRef idx="minor">
-            <a:schemeClr val="tx1"/>
-          </a:fontRef>
-        </p:style>
-      </p:cxnSp>
-      <p:cxnSp>
-        <p:nvCxnSpPr>
-          <p:cNvPr id="10" name="Straight Connector 9">
-            <a:extLst>
-              <a:ext uri="{FF2B5EF4-FFF2-40B4-BE49-F238E27FC236}">
-                <a16:creationId xmlns:a16="http://schemas.microsoft.com/office/drawing/2014/main" id="{277035DE-D28A-5B82-3460-1381A717BD51}"/>
-              </a:ext>
-            </a:extLst>
-          </p:cNvPr>
-          <p:cNvCxnSpPr/>
-          <p:nvPr/>
-        </p:nvCxnSpPr>
-        <p:spPr>
-          <a:xfrm>
-            <a:off x="5948979" y="4670612"/>
-            <a:ext cx="2520000" cy="0"/>
-          </a:xfrm>
-          <a:prstGeom prst="line">
-            <a:avLst/>
-          </a:prstGeom>
-          <a:ln>
-            <a:solidFill>
-              <a:srgbClr val="FF0000"/>
-            </a:solidFill>
-          </a:ln>
-        </p:spPr>
-        <p:style>
-          <a:lnRef idx="2">
-            <a:schemeClr val="accent1"/>
-          </a:lnRef>
-          <a:fillRef idx="0">
-            <a:schemeClr val="accent1"/>
-          </a:fillRef>
-          <a:effectRef idx="1">
-            <a:schemeClr val="accent1"/>
-          </a:effectRef>
-          <a:fontRef idx="minor">
-            <a:schemeClr val="tx1"/>
-          </a:fontRef>
-        </p:style>
-      </p:cxnSp>
-      <p:cxnSp>
-        <p:nvCxnSpPr>
-          <p:cNvPr id="11" name="Straight Connector 10">
-            <a:extLst>
-              <a:ext uri="{FF2B5EF4-FFF2-40B4-BE49-F238E27FC236}">
-                <a16:creationId xmlns:a16="http://schemas.microsoft.com/office/drawing/2014/main" id="{78285F3A-214C-02E9-8A98-3E5D133ADD75}"/>
-              </a:ext>
-            </a:extLst>
-          </p:cNvPr>
-          <p:cNvCxnSpPr/>
-          <p:nvPr/>
-        </p:nvCxnSpPr>
-        <p:spPr>
-          <a:xfrm>
-            <a:off x="6305774" y="4543313"/>
-            <a:ext cx="2520000" cy="0"/>
-          </a:xfrm>
-          <a:prstGeom prst="line">
-            <a:avLst/>
-          </a:prstGeom>
-          <a:ln>
-            <a:solidFill>
-              <a:srgbClr val="FF0000"/>
-            </a:solidFill>
-          </a:ln>
-        </p:spPr>
-        <p:style>
-          <a:lnRef idx="2">
-            <a:schemeClr val="accent1"/>
-          </a:lnRef>
-          <a:fillRef idx="0">
-            <a:schemeClr val="accent1"/>
-          </a:fillRef>
-          <a:effectRef idx="1">
-            <a:schemeClr val="accent1"/>
-          </a:effectRef>
-          <a:fontRef idx="minor">
-            <a:schemeClr val="tx1"/>
-          </a:fontRef>
-        </p:style>
-      </p:cxnSp>
-      <p:cxnSp>
-        <p:nvCxnSpPr>
-          <p:cNvPr id="12" name="Straight Connector 11">
-            <a:extLst>
-              <a:ext uri="{FF2B5EF4-FFF2-40B4-BE49-F238E27FC236}">
-                <a16:creationId xmlns:a16="http://schemas.microsoft.com/office/drawing/2014/main" id="{77FA12A9-2258-E8DD-4D49-F6040F5E0066}"/>
-              </a:ext>
-            </a:extLst>
-          </p:cNvPr>
-          <p:cNvCxnSpPr/>
-          <p:nvPr/>
-        </p:nvCxnSpPr>
-        <p:spPr>
-          <a:xfrm>
-            <a:off x="6736080" y="4420409"/>
-            <a:ext cx="2520000" cy="0"/>
-          </a:xfrm>
-          <a:prstGeom prst="line">
-            <a:avLst/>
-          </a:prstGeom>
-          <a:ln>
-            <a:solidFill>
-              <a:srgbClr val="FF0000"/>
-            </a:solidFill>
-          </a:ln>
-        </p:spPr>
-        <p:style>
-          <a:lnRef idx="2">
-            <a:schemeClr val="accent1"/>
-          </a:lnRef>
-          <a:fillRef idx="0">
-            <a:schemeClr val="accent1"/>
-          </a:fillRef>
-          <a:effectRef idx="1">
-            <a:schemeClr val="accent1"/>
-          </a:effectRef>
-          <a:fontRef idx="minor">
-            <a:schemeClr val="tx1"/>
-          </a:fontRef>
-        </p:style>
-      </p:cxnSp>
-      <p:cxnSp>
-        <p:nvCxnSpPr>
-          <p:cNvPr id="13" name="Straight Connector 12">
-            <a:extLst>
-              <a:ext uri="{FF2B5EF4-FFF2-40B4-BE49-F238E27FC236}">
-                <a16:creationId xmlns:a16="http://schemas.microsoft.com/office/drawing/2014/main" id="{5E6C300E-DA39-D831-EED5-5032FDF7DF7C}"/>
-              </a:ext>
-            </a:extLst>
-          </p:cNvPr>
-          <p:cNvCxnSpPr/>
-          <p:nvPr/>
-        </p:nvCxnSpPr>
-        <p:spPr>
-          <a:xfrm>
-            <a:off x="7318786" y="4271595"/>
-            <a:ext cx="2520000" cy="0"/>
-          </a:xfrm>
-          <a:prstGeom prst="line">
-            <a:avLst/>
-          </a:prstGeom>
-          <a:ln>
-            <a:solidFill>
-              <a:srgbClr val="FF0000"/>
-            </a:solidFill>
-          </a:ln>
-        </p:spPr>
-        <p:style>
-          <a:lnRef idx="2">
-            <a:schemeClr val="accent1"/>
-          </a:lnRef>
-          <a:fillRef idx="0">
-            <a:schemeClr val="accent1"/>
-          </a:fillRef>
-          <a:effectRef idx="1">
-            <a:schemeClr val="accent1"/>
-          </a:effectRef>
-          <a:fontRef idx="minor">
-            <a:schemeClr val="tx1"/>
-          </a:fontRef>
-        </p:style>
-      </p:cxnSp>
-      <p:sp>
-        <p:nvSpPr>
-          <p:cNvPr id="14" name="TextBox 13">
-            <a:extLst>
-              <a:ext uri="{FF2B5EF4-FFF2-40B4-BE49-F238E27FC236}">
-                <a16:creationId xmlns:a16="http://schemas.microsoft.com/office/drawing/2014/main" id="{D74D4712-99D4-CE9D-C759-3ED5D9276710}"/>
-              </a:ext>
-            </a:extLst>
-          </p:cNvPr>
-          <p:cNvSpPr txBox="1"/>
-          <p:nvPr/>
-        </p:nvSpPr>
-        <p:spPr>
-          <a:xfrm>
-            <a:off x="8070762" y="3923779"/>
-            <a:ext cx="1223412" cy="369332"/>
+            <a:off x="6100915" y="2726175"/>
+            <a:ext cx="4500563" cy="3450788"/>
           </a:xfrm>
           <a:prstGeom prst="rect">
             <a:avLst/>
           </a:prstGeom>
           <a:noFill/>
-        </p:spPr>
-        <p:txBody>
-          <a:bodyPr wrap="none" rtlCol="0">
-            <a:spAutoFit/>
-          </a:bodyPr>
-          <a:lstStyle/>
-          <a:p>
-            <a:r>
-              <a:rPr lang="en-US" dirty="0">
+          <a:extLst>
+            <a:ext uri="{909E8E84-426E-40DD-AFC4-6F175D3DCCD1}">
+              <a14:hiddenFill xmlns:a14="http://schemas.microsoft.com/office/drawing/2010/main">
                 <a:solidFill>
-                  <a:srgbClr val="FF0000"/>
+                  <a:srgbClr val="FFFFFF"/>
                 </a:solidFill>
-              </a:rPr>
-              <a:t>Span = 0.5</a:t>
-            </a:r>
-          </a:p>
-        </p:txBody>
-      </p:sp>
-      <p:sp>
-        <p:nvSpPr>
-          <p:cNvPr id="15" name="TextBox 14">
-            <a:extLst>
-              <a:ext uri="{FF2B5EF4-FFF2-40B4-BE49-F238E27FC236}">
-                <a16:creationId xmlns:a16="http://schemas.microsoft.com/office/drawing/2014/main" id="{ECCB83A4-8E5C-F07F-D6D3-D7C3F3FE5A74}"/>
+              </a14:hiddenFill>
+            </a:ext>
+          </a:extLst>
+        </p:spPr>
+      </p:pic>
+      <p:sp>
+        <p:nvSpPr>
+          <p:cNvPr id="5" name="TextBox 4">
+            <a:extLst>
+              <a:ext uri="{FF2B5EF4-FFF2-40B4-BE49-F238E27FC236}">
+                <a16:creationId xmlns:a16="http://schemas.microsoft.com/office/drawing/2014/main" id="{E61A2CE3-AA95-1EAC-2FE4-F819DBE5BE47}"/>
               </a:ext>
             </a:extLst>
           </p:cNvPr>
@@ -4206,8 +3973,8 @@
         </p:nvSpPr>
         <p:spPr>
           <a:xfrm>
-            <a:off x="9655582" y="4513656"/>
-            <a:ext cx="1034257" cy="369332"/>
+            <a:off x="4693495" y="6488668"/>
+            <a:ext cx="7315401" cy="369332"/>
           </a:xfrm>
           <a:prstGeom prst="rect">
             <a:avLst/>
@@ -4221,12 +3988,16 @@
           <a:lstStyle/>
           <a:p>
             <a:r>
-              <a:rPr lang="en-US" dirty="0">
-                <a:solidFill>
-                  <a:srgbClr val="0070C0"/>
-                </a:solidFill>
-              </a:rPr>
-              <a:t>Span = 1</a:t>
+              <a:rPr lang="en-US" dirty="0"/>
+              <a:t>Figure from Fonville et al. 2014 https://</a:t>
+            </a:r>
+            <a:r>
+              <a:rPr lang="en-US" dirty="0" err="1"/>
+              <a:t>doi.org</a:t>
+            </a:r>
+            <a:r>
+              <a:rPr lang="en-US" dirty="0"/>
+              <a:t>/10.1126/science.1256427</a:t>
             </a:r>
           </a:p>
         </p:txBody>
@@ -4234,7 +4005,7 @@
     </p:spTree>
     <p:extLst>
       <p:ext uri="{BB962C8B-B14F-4D97-AF65-F5344CB8AC3E}">
-        <p14:creationId xmlns:p14="http://schemas.microsoft.com/office/powerpoint/2010/main" val="2378136460"/>
+        <p14:creationId xmlns:p14="http://schemas.microsoft.com/office/powerpoint/2010/main" val="1433763790"/>
       </p:ext>
     </p:extLst>
   </p:cSld>
@@ -4266,7 +4037,7 @@
           <p:cNvPr id="2" name="Title 1">
             <a:extLst>
               <a:ext uri="{FF2B5EF4-FFF2-40B4-BE49-F238E27FC236}">
-                <a16:creationId xmlns:a16="http://schemas.microsoft.com/office/drawing/2014/main" id="{C607B642-90B5-3A5D-B803-AEED63E14F97}"/>
+                <a16:creationId xmlns:a16="http://schemas.microsoft.com/office/drawing/2014/main" id="{69664FC9-5CAD-F2F9-1DC8-1E67AD2A44E9}"/>
               </a:ext>
             </a:extLst>
           </p:cNvPr>
@@ -4276,196 +4047,108 @@
           <p:nvPr>
             <p:ph type="title"/>
           </p:nvPr>
+        </p:nvSpPr>
+        <p:spPr/>
+        <p:txBody>
+          <a:bodyPr/>
+          <a:lstStyle/>
+          <a:p>
+            <a:r>
+              <a:rPr lang="en-US" dirty="0"/>
+              <a:t>LO(W)ESS</a:t>
+            </a:r>
+          </a:p>
+        </p:txBody>
+      </p:sp>
+      <p:sp>
+        <p:nvSpPr>
+          <p:cNvPr id="5" name="TextBox 4">
+            <a:extLst>
+              <a:ext uri="{FF2B5EF4-FFF2-40B4-BE49-F238E27FC236}">
+                <a16:creationId xmlns:a16="http://schemas.microsoft.com/office/drawing/2014/main" id="{0D4A0B6B-F182-FB9F-8FBC-A44EB4EEE43D}"/>
+              </a:ext>
+            </a:extLst>
+          </p:cNvPr>
+          <p:cNvSpPr txBox="1"/>
+          <p:nvPr/>
         </p:nvSpPr>
         <p:spPr>
           <a:xfrm>
-            <a:off x="838200" y="-301218"/>
-            <a:ext cx="10515600" cy="1325563"/>
-          </a:xfrm>
-        </p:spPr>
-        <p:txBody>
-          <a:bodyPr/>
+            <a:off x="483198" y="2119257"/>
+            <a:ext cx="4250168" cy="3139321"/>
+          </a:xfrm>
+          <a:prstGeom prst="rect">
+            <a:avLst/>
+          </a:prstGeom>
+          <a:noFill/>
+        </p:spPr>
+        <p:txBody>
+          <a:bodyPr wrap="square" rtlCol="0">
+            <a:spAutoFit/>
+          </a:bodyPr>
           <a:lstStyle/>
           <a:p>
             <a:r>
               <a:rPr lang="en-US" dirty="0"/>
-              <a:t>Parameter optimization</a:t>
-            </a:r>
-          </a:p>
-        </p:txBody>
-      </p:sp>
-      <p:sp>
-        <p:nvSpPr>
-          <p:cNvPr id="3" name="Content Placeholder 2">
-            <a:extLst>
-              <a:ext uri="{FF2B5EF4-FFF2-40B4-BE49-F238E27FC236}">
-                <a16:creationId xmlns:a16="http://schemas.microsoft.com/office/drawing/2014/main" id="{A739CA0B-74C8-E9F9-9835-F15F2F80FF84}"/>
-              </a:ext>
-            </a:extLst>
-          </p:cNvPr>
-          <p:cNvSpPr>
-            <a:spLocks noGrp="1"/>
-          </p:cNvSpPr>
-          <p:nvPr>
-            <p:ph idx="1"/>
-          </p:nvPr>
-        </p:nvSpPr>
-        <p:spPr>
-          <a:xfrm>
-            <a:off x="255105" y="801786"/>
-            <a:ext cx="10515600" cy="4351338"/>
-          </a:xfrm>
-        </p:spPr>
-        <p:txBody>
-          <a:bodyPr/>
-          <a:lstStyle/>
+              <a:t>Fit local polynomial regression</a:t>
+            </a:r>
+          </a:p>
+          <a:p>
+            <a:endParaRPr lang="en-US" dirty="0"/>
+          </a:p>
           <a:p>
             <a:r>
               <a:rPr lang="en-US" dirty="0"/>
-              <a:t>Optimize parameters such that likelihood to obtain measured value with the given parameter set is maximized</a:t>
-            </a:r>
+              <a:t>Degree of polynomial (here 1)</a:t>
+            </a:r>
+          </a:p>
+          <a:p>
+            <a:endParaRPr lang="en-US" dirty="0"/>
           </a:p>
           <a:p>
             <a:r>
               <a:rPr lang="en-US" dirty="0"/>
-              <a:t>Likelihood modelled as normal distribution with</a:t>
-            </a:r>
-          </a:p>
-          <a:p>
-            <a:pPr lvl="1"/>
-            <a:r>
-              <a:rPr lang="en-US" dirty="0"/>
-              <a:t>Mean = fitted value</a:t>
-            </a:r>
-          </a:p>
-          <a:p>
-            <a:pPr lvl="1"/>
-            <a:r>
-              <a:rPr lang="en-US" dirty="0"/>
-              <a:t>SD = user input (the wider, the </a:t>
+              <a:t>Span (bandwidth) = How many points to include in local regression, often fraction of data points</a:t>
             </a:r>
             <a:br>
               <a:rPr lang="en-US" dirty="0"/>
             </a:br>
             <a:r>
               <a:rPr lang="en-US" dirty="0"/>
-              <a:t>more likely large difference </a:t>
-            </a:r>
-            <a:br>
-              <a:rPr lang="en-US" dirty="0"/>
-            </a:br>
-            <a:r>
-              <a:rPr lang="en-US" dirty="0"/>
-              <a:t>between fitted and measured value)</a:t>
-            </a:r>
-          </a:p>
-          <a:p>
-            <a:pPr lvl="1"/>
-            <a:endParaRPr lang="en-US" dirty="0"/>
-          </a:p>
-          <a:p>
-            <a:pPr lvl="1"/>
+              <a:t>(larger span </a:t>
+            </a:r>
             <a:r>
               <a:rPr lang="en-US" dirty="0">
                 <a:sym typeface="Wingdings" pitchFamily="2" charset="2"/>
               </a:rPr>
-              <a:t> How likely is </a:t>
-            </a:r>
-            <a:r>
-              <a:rPr lang="en-US" dirty="0">
-                <a:solidFill>
-                  <a:srgbClr val="FF0000"/>
-                </a:solidFill>
-                <a:sym typeface="Wingdings" pitchFamily="2" charset="2"/>
-              </a:rPr>
-              <a:t>measuring the input </a:t>
-            </a:r>
-            <a:br>
-              <a:rPr lang="en-US" dirty="0">
-                <a:solidFill>
-                  <a:srgbClr val="FF0000"/>
-                </a:solidFill>
-                <a:sym typeface="Wingdings" pitchFamily="2" charset="2"/>
-              </a:rPr>
-            </a:br>
-            <a:r>
-              <a:rPr lang="en-US" dirty="0" err="1">
-                <a:solidFill>
-                  <a:srgbClr val="FF0000"/>
-                </a:solidFill>
-                <a:sym typeface="Wingdings" pitchFamily="2" charset="2"/>
-              </a:rPr>
-              <a:t>logtiter</a:t>
-            </a:r>
+              <a:t> more points included)</a:t>
+            </a:r>
+          </a:p>
+          <a:p>
+            <a:endParaRPr lang="en-US" dirty="0">
+              <a:sym typeface="Wingdings" pitchFamily="2" charset="2"/>
+            </a:endParaRPr>
+          </a:p>
+          <a:p>
             <a:r>
               <a:rPr lang="en-US" dirty="0">
                 <a:sym typeface="Wingdings" pitchFamily="2" charset="2"/>
               </a:rPr>
-              <a:t> when the </a:t>
-            </a:r>
-            <a:r>
-              <a:rPr lang="en-US" dirty="0">
-                <a:solidFill>
-                  <a:schemeClr val="tx2">
-                    <a:lumMod val="50000"/>
-                    <a:lumOff val="50000"/>
-                  </a:schemeClr>
-                </a:solidFill>
-                <a:sym typeface="Wingdings" pitchFamily="2" charset="2"/>
-              </a:rPr>
-              <a:t>expected value </a:t>
-            </a:r>
-            <a:br>
-              <a:rPr lang="en-US" dirty="0">
-                <a:solidFill>
-                  <a:schemeClr val="tx2">
-                    <a:lumMod val="50000"/>
-                    <a:lumOff val="50000"/>
-                  </a:schemeClr>
-                </a:solidFill>
-                <a:sym typeface="Wingdings" pitchFamily="2" charset="2"/>
-              </a:rPr>
-            </a:br>
-            <a:r>
-              <a:rPr lang="en-US" dirty="0">
-                <a:solidFill>
-                  <a:schemeClr val="tx2">
-                    <a:lumMod val="50000"/>
-                    <a:lumOff val="50000"/>
-                  </a:schemeClr>
-                </a:solidFill>
-                <a:sym typeface="Wingdings" pitchFamily="2" charset="2"/>
-              </a:rPr>
-              <a:t>is the fitted </a:t>
-            </a:r>
-            <a:r>
-              <a:rPr lang="en-US" dirty="0" err="1">
-                <a:solidFill>
-                  <a:schemeClr val="tx2">
-                    <a:lumMod val="50000"/>
-                    <a:lumOff val="50000"/>
-                  </a:schemeClr>
-                </a:solidFill>
-                <a:sym typeface="Wingdings" pitchFamily="2" charset="2"/>
-              </a:rPr>
-              <a:t>logtiter</a:t>
-            </a:r>
-            <a:r>
-              <a:rPr lang="en-US" dirty="0">
-                <a:sym typeface="Wingdings" pitchFamily="2" charset="2"/>
-              </a:rPr>
-              <a:t>?</a:t>
-            </a:r>
+              <a:t>Points in the center are weighted more</a:t>
+            </a:r>
+            <a:endParaRPr lang="en-US" dirty="0"/>
+          </a:p>
+          <a:p>
             <a:endParaRPr lang="en-US" dirty="0"/>
           </a:p>
         </p:txBody>
       </p:sp>
       <p:pic>
         <p:nvPicPr>
-          <p:cNvPr id="5" name="Picture 4">
-            <a:extLst>
-              <a:ext uri="{FF2B5EF4-FFF2-40B4-BE49-F238E27FC236}">
-                <a16:creationId xmlns:a16="http://schemas.microsoft.com/office/drawing/2014/main" id="{9E24B51C-906C-A3A7-C9D9-CA4665C1A9CF}"/>
+          <p:cNvPr id="7" name="Picture 6">
+            <a:extLst>
+              <a:ext uri="{FF2B5EF4-FFF2-40B4-BE49-F238E27FC236}">
+                <a16:creationId xmlns:a16="http://schemas.microsoft.com/office/drawing/2014/main" id="{89DABC51-F894-890C-087F-3503984F22D2}"/>
               </a:ext>
             </a:extLst>
           </p:cNvPr>
@@ -4482,20 +4165,228 @@
         </p:blipFill>
         <p:spPr>
           <a:xfrm>
-            <a:off x="6277665" y="2140601"/>
-            <a:ext cx="5530022" cy="4231228"/>
+            <a:off x="4787302" y="527050"/>
+            <a:ext cx="6921500" cy="5803900"/>
           </a:xfrm>
           <a:prstGeom prst="rect">
             <a:avLst/>
           </a:prstGeom>
         </p:spPr>
       </p:pic>
-      <p:sp>
-        <p:nvSpPr>
-          <p:cNvPr id="6" name="TextBox 5">
-            <a:extLst>
-              <a:ext uri="{FF2B5EF4-FFF2-40B4-BE49-F238E27FC236}">
-                <a16:creationId xmlns:a16="http://schemas.microsoft.com/office/drawing/2014/main" id="{38D48167-8CAB-503E-005A-5ACFD9045D96}"/>
+      <p:cxnSp>
+        <p:nvCxnSpPr>
+          <p:cNvPr id="9" name="Straight Connector 8">
+            <a:extLst>
+              <a:ext uri="{FF2B5EF4-FFF2-40B4-BE49-F238E27FC236}">
+                <a16:creationId xmlns:a16="http://schemas.microsoft.com/office/drawing/2014/main" id="{75578EF3-FC25-BCBA-64BF-503F32937C40}"/>
+              </a:ext>
+            </a:extLst>
+          </p:cNvPr>
+          <p:cNvCxnSpPr/>
+          <p:nvPr/>
+        </p:nvCxnSpPr>
+        <p:spPr>
+          <a:xfrm>
+            <a:off x="5948979" y="4873214"/>
+            <a:ext cx="5099125" cy="0"/>
+          </a:xfrm>
+          <a:prstGeom prst="line">
+            <a:avLst/>
+          </a:prstGeom>
+          <a:ln>
+            <a:solidFill>
+              <a:schemeClr val="tx2">
+                <a:lumMod val="50000"/>
+                <a:lumOff val="50000"/>
+              </a:schemeClr>
+            </a:solidFill>
+          </a:ln>
+        </p:spPr>
+        <p:style>
+          <a:lnRef idx="2">
+            <a:schemeClr val="accent1"/>
+          </a:lnRef>
+          <a:fillRef idx="0">
+            <a:schemeClr val="accent1"/>
+          </a:fillRef>
+          <a:effectRef idx="1">
+            <a:schemeClr val="accent1"/>
+          </a:effectRef>
+          <a:fontRef idx="minor">
+            <a:schemeClr val="tx1"/>
+          </a:fontRef>
+        </p:style>
+      </p:cxnSp>
+      <p:cxnSp>
+        <p:nvCxnSpPr>
+          <p:cNvPr id="10" name="Straight Connector 9">
+            <a:extLst>
+              <a:ext uri="{FF2B5EF4-FFF2-40B4-BE49-F238E27FC236}">
+                <a16:creationId xmlns:a16="http://schemas.microsoft.com/office/drawing/2014/main" id="{277035DE-D28A-5B82-3460-1381A717BD51}"/>
+              </a:ext>
+            </a:extLst>
+          </p:cNvPr>
+          <p:cNvCxnSpPr/>
+          <p:nvPr/>
+        </p:nvCxnSpPr>
+        <p:spPr>
+          <a:xfrm>
+            <a:off x="5948979" y="4670612"/>
+            <a:ext cx="2520000" cy="0"/>
+          </a:xfrm>
+          <a:prstGeom prst="line">
+            <a:avLst/>
+          </a:prstGeom>
+          <a:ln>
+            <a:solidFill>
+              <a:srgbClr val="FF0000"/>
+            </a:solidFill>
+          </a:ln>
+        </p:spPr>
+        <p:style>
+          <a:lnRef idx="2">
+            <a:schemeClr val="accent1"/>
+          </a:lnRef>
+          <a:fillRef idx="0">
+            <a:schemeClr val="accent1"/>
+          </a:fillRef>
+          <a:effectRef idx="1">
+            <a:schemeClr val="accent1"/>
+          </a:effectRef>
+          <a:fontRef idx="minor">
+            <a:schemeClr val="tx1"/>
+          </a:fontRef>
+        </p:style>
+      </p:cxnSp>
+      <p:cxnSp>
+        <p:nvCxnSpPr>
+          <p:cNvPr id="11" name="Straight Connector 10">
+            <a:extLst>
+              <a:ext uri="{FF2B5EF4-FFF2-40B4-BE49-F238E27FC236}">
+                <a16:creationId xmlns:a16="http://schemas.microsoft.com/office/drawing/2014/main" id="{78285F3A-214C-02E9-8A98-3E5D133ADD75}"/>
+              </a:ext>
+            </a:extLst>
+          </p:cNvPr>
+          <p:cNvCxnSpPr/>
+          <p:nvPr/>
+        </p:nvCxnSpPr>
+        <p:spPr>
+          <a:xfrm>
+            <a:off x="6305774" y="4543313"/>
+            <a:ext cx="2520000" cy="0"/>
+          </a:xfrm>
+          <a:prstGeom prst="line">
+            <a:avLst/>
+          </a:prstGeom>
+          <a:ln>
+            <a:solidFill>
+              <a:srgbClr val="FF0000"/>
+            </a:solidFill>
+          </a:ln>
+        </p:spPr>
+        <p:style>
+          <a:lnRef idx="2">
+            <a:schemeClr val="accent1"/>
+          </a:lnRef>
+          <a:fillRef idx="0">
+            <a:schemeClr val="accent1"/>
+          </a:fillRef>
+          <a:effectRef idx="1">
+            <a:schemeClr val="accent1"/>
+          </a:effectRef>
+          <a:fontRef idx="minor">
+            <a:schemeClr val="tx1"/>
+          </a:fontRef>
+        </p:style>
+      </p:cxnSp>
+      <p:cxnSp>
+        <p:nvCxnSpPr>
+          <p:cNvPr id="12" name="Straight Connector 11">
+            <a:extLst>
+              <a:ext uri="{FF2B5EF4-FFF2-40B4-BE49-F238E27FC236}">
+                <a16:creationId xmlns:a16="http://schemas.microsoft.com/office/drawing/2014/main" id="{77FA12A9-2258-E8DD-4D49-F6040F5E0066}"/>
+              </a:ext>
+            </a:extLst>
+          </p:cNvPr>
+          <p:cNvCxnSpPr/>
+          <p:nvPr/>
+        </p:nvCxnSpPr>
+        <p:spPr>
+          <a:xfrm>
+            <a:off x="6736080" y="4420409"/>
+            <a:ext cx="2520000" cy="0"/>
+          </a:xfrm>
+          <a:prstGeom prst="line">
+            <a:avLst/>
+          </a:prstGeom>
+          <a:ln>
+            <a:solidFill>
+              <a:srgbClr val="FF0000"/>
+            </a:solidFill>
+          </a:ln>
+        </p:spPr>
+        <p:style>
+          <a:lnRef idx="2">
+            <a:schemeClr val="accent1"/>
+          </a:lnRef>
+          <a:fillRef idx="0">
+            <a:schemeClr val="accent1"/>
+          </a:fillRef>
+          <a:effectRef idx="1">
+            <a:schemeClr val="accent1"/>
+          </a:effectRef>
+          <a:fontRef idx="minor">
+            <a:schemeClr val="tx1"/>
+          </a:fontRef>
+        </p:style>
+      </p:cxnSp>
+      <p:cxnSp>
+        <p:nvCxnSpPr>
+          <p:cNvPr id="13" name="Straight Connector 12">
+            <a:extLst>
+              <a:ext uri="{FF2B5EF4-FFF2-40B4-BE49-F238E27FC236}">
+                <a16:creationId xmlns:a16="http://schemas.microsoft.com/office/drawing/2014/main" id="{5E6C300E-DA39-D831-EED5-5032FDF7DF7C}"/>
+              </a:ext>
+            </a:extLst>
+          </p:cNvPr>
+          <p:cNvCxnSpPr/>
+          <p:nvPr/>
+        </p:nvCxnSpPr>
+        <p:spPr>
+          <a:xfrm>
+            <a:off x="7318786" y="4271595"/>
+            <a:ext cx="2520000" cy="0"/>
+          </a:xfrm>
+          <a:prstGeom prst="line">
+            <a:avLst/>
+          </a:prstGeom>
+          <a:ln>
+            <a:solidFill>
+              <a:srgbClr val="FF0000"/>
+            </a:solidFill>
+          </a:ln>
+        </p:spPr>
+        <p:style>
+          <a:lnRef idx="2">
+            <a:schemeClr val="accent1"/>
+          </a:lnRef>
+          <a:fillRef idx="0">
+            <a:schemeClr val="accent1"/>
+          </a:fillRef>
+          <a:effectRef idx="1">
+            <a:schemeClr val="accent1"/>
+          </a:effectRef>
+          <a:fontRef idx="minor">
+            <a:schemeClr val="tx1"/>
+          </a:fontRef>
+        </p:style>
+      </p:cxnSp>
+      <p:sp>
+        <p:nvSpPr>
+          <p:cNvPr id="14" name="TextBox 13">
+            <a:extLst>
+              <a:ext uri="{FF2B5EF4-FFF2-40B4-BE49-F238E27FC236}">
+                <a16:creationId xmlns:a16="http://schemas.microsoft.com/office/drawing/2014/main" id="{D74D4712-99D4-CE9D-C759-3ED5D9276710}"/>
               </a:ext>
             </a:extLst>
           </p:cNvPr>
@@ -4504,153 +4395,8 @@
         </p:nvSpPr>
         <p:spPr>
           <a:xfrm>
-            <a:off x="10563949" y="5208478"/>
-            <a:ext cx="813043" cy="369332"/>
-          </a:xfrm>
-          <a:prstGeom prst="rect">
-            <a:avLst/>
-          </a:prstGeom>
-          <a:noFill/>
-        </p:spPr>
-        <p:txBody>
-          <a:bodyPr wrap="none" rtlCol="0">
-            <a:spAutoFit/>
-          </a:bodyPr>
-          <a:lstStyle/>
-          <a:p>
-            <a:r>
-              <a:rPr lang="en-US" dirty="0">
-                <a:solidFill>
-                  <a:schemeClr val="bg1">
-                    <a:lumMod val="65000"/>
-                  </a:schemeClr>
-                </a:solidFill>
-              </a:rPr>
-              <a:t>SD = 2</a:t>
-            </a:r>
-          </a:p>
-        </p:txBody>
-      </p:sp>
-      <p:sp>
-        <p:nvSpPr>
-          <p:cNvPr id="7" name="TextBox 6">
-            <a:extLst>
-              <a:ext uri="{FF2B5EF4-FFF2-40B4-BE49-F238E27FC236}">
-                <a16:creationId xmlns:a16="http://schemas.microsoft.com/office/drawing/2014/main" id="{8AEF4501-B1C3-0A50-D8B3-618F2AC3DDE8}"/>
-              </a:ext>
-            </a:extLst>
-          </p:cNvPr>
-          <p:cNvSpPr txBox="1"/>
-          <p:nvPr/>
-        </p:nvSpPr>
-        <p:spPr>
-          <a:xfrm>
-            <a:off x="9338123" y="3886883"/>
-            <a:ext cx="813043" cy="369332"/>
-          </a:xfrm>
-          <a:prstGeom prst="rect">
-            <a:avLst/>
-          </a:prstGeom>
-          <a:noFill/>
-        </p:spPr>
-        <p:txBody>
-          <a:bodyPr wrap="none" rtlCol="0">
-            <a:spAutoFit/>
-          </a:bodyPr>
-          <a:lstStyle/>
-          <a:p>
-            <a:r>
-              <a:rPr lang="en-US" dirty="0">
-                <a:solidFill>
-                  <a:schemeClr val="bg2">
-                    <a:lumMod val="50000"/>
-                  </a:schemeClr>
-                </a:solidFill>
-              </a:rPr>
-              <a:t>SD = 1</a:t>
-            </a:r>
-          </a:p>
-        </p:txBody>
-      </p:sp>
-      <p:sp>
-        <p:nvSpPr>
-          <p:cNvPr id="8" name="TextBox 7">
-            <a:extLst>
-              <a:ext uri="{FF2B5EF4-FFF2-40B4-BE49-F238E27FC236}">
-                <a16:creationId xmlns:a16="http://schemas.microsoft.com/office/drawing/2014/main" id="{02DAFA0E-7D18-F465-B001-54075973F9B2}"/>
-              </a:ext>
-            </a:extLst>
-          </p:cNvPr>
-          <p:cNvSpPr txBox="1"/>
-          <p:nvPr/>
-        </p:nvSpPr>
-        <p:spPr>
-          <a:xfrm>
-            <a:off x="7648687" y="2216075"/>
-            <a:ext cx="885627" cy="646331"/>
-          </a:xfrm>
-          <a:prstGeom prst="rect">
-            <a:avLst/>
-          </a:prstGeom>
-          <a:noFill/>
-        </p:spPr>
-        <p:txBody>
-          <a:bodyPr wrap="none" rtlCol="0">
-            <a:spAutoFit/>
-          </a:bodyPr>
-          <a:lstStyle/>
-          <a:p>
-            <a:r>
-              <a:rPr lang="en-US" dirty="0">
-                <a:solidFill>
-                  <a:schemeClr val="tx2">
-                    <a:lumMod val="75000"/>
-                    <a:lumOff val="25000"/>
-                  </a:schemeClr>
-                </a:solidFill>
-              </a:rPr>
-              <a:t>Fitted </a:t>
-            </a:r>
-          </a:p>
-          <a:p>
-            <a:r>
-              <a:rPr lang="en-US" dirty="0" err="1">
-                <a:solidFill>
-                  <a:schemeClr val="tx2">
-                    <a:lumMod val="75000"/>
-                    <a:lumOff val="25000"/>
-                  </a:schemeClr>
-                </a:solidFill>
-              </a:rPr>
-              <a:t>logtiter</a:t>
-            </a:r>
-            <a:endParaRPr lang="en-US" dirty="0">
-              <a:solidFill>
-                <a:schemeClr val="tx2">
-                  <a:lumMod val="75000"/>
-                  <a:lumOff val="25000"/>
-                </a:schemeClr>
-              </a:solidFill>
-            </a:endParaRPr>
-          </a:p>
-        </p:txBody>
-      </p:sp>
-      <p:sp>
-        <p:nvSpPr>
-          <p:cNvPr id="9" name="TextBox 8">
-            <a:extLst>
-              <a:ext uri="{FF2B5EF4-FFF2-40B4-BE49-F238E27FC236}">
-                <a16:creationId xmlns:a16="http://schemas.microsoft.com/office/drawing/2014/main" id="{91BBC275-B5AA-D3C3-CF0D-5905DE3A6AFF}"/>
-              </a:ext>
-            </a:extLst>
-          </p:cNvPr>
-          <p:cNvSpPr txBox="1"/>
-          <p:nvPr/>
-        </p:nvSpPr>
-        <p:spPr>
-          <a:xfrm>
-            <a:off x="9089705" y="2216075"/>
-            <a:ext cx="1225079" cy="646331"/>
+            <a:off x="8070762" y="3923779"/>
+            <a:ext cx="1223412" cy="369332"/>
           </a:xfrm>
           <a:prstGeom prst="rect">
             <a:avLst/>
@@ -4669,35 +4415,54 @@
                   <a:srgbClr val="FF0000"/>
                 </a:solidFill>
               </a:rPr>
-              <a:t>Measured </a:t>
-            </a:r>
-            <a:br>
+              <a:t>Span = 0.5</a:t>
+            </a:r>
+          </a:p>
+        </p:txBody>
+      </p:sp>
+      <p:sp>
+        <p:nvSpPr>
+          <p:cNvPr id="15" name="TextBox 14">
+            <a:extLst>
+              <a:ext uri="{FF2B5EF4-FFF2-40B4-BE49-F238E27FC236}">
+                <a16:creationId xmlns:a16="http://schemas.microsoft.com/office/drawing/2014/main" id="{ECCB83A4-8E5C-F07F-D6D3-D7C3F3FE5A74}"/>
+              </a:ext>
+            </a:extLst>
+          </p:cNvPr>
+          <p:cNvSpPr txBox="1"/>
+          <p:nvPr/>
+        </p:nvSpPr>
+        <p:spPr>
+          <a:xfrm>
+            <a:off x="9655582" y="4513656"/>
+            <a:ext cx="1034257" cy="369332"/>
+          </a:xfrm>
+          <a:prstGeom prst="rect">
+            <a:avLst/>
+          </a:prstGeom>
+          <a:noFill/>
+        </p:spPr>
+        <p:txBody>
+          <a:bodyPr wrap="none" rtlCol="0">
+            <a:spAutoFit/>
+          </a:bodyPr>
+          <a:lstStyle/>
+          <a:p>
+            <a:r>
               <a:rPr lang="en-US" dirty="0">
                 <a:solidFill>
-                  <a:srgbClr val="FF0000"/>
+                  <a:srgbClr val="0070C0"/>
                 </a:solidFill>
               </a:rPr>
-            </a:br>
-            <a:r>
-              <a:rPr lang="en-US" dirty="0" err="1">
-                <a:solidFill>
-                  <a:srgbClr val="FF0000"/>
-                </a:solidFill>
-              </a:rPr>
-              <a:t>logtiter</a:t>
-            </a:r>
-            <a:endParaRPr lang="en-US" dirty="0">
-              <a:solidFill>
-                <a:srgbClr val="FF0000"/>
-              </a:solidFill>
-            </a:endParaRPr>
+              <a:t>Span = 1</a:t>
+            </a:r>
           </a:p>
         </p:txBody>
       </p:sp>
     </p:spTree>
     <p:extLst>
       <p:ext uri="{BB962C8B-B14F-4D97-AF65-F5344CB8AC3E}">
-        <p14:creationId xmlns:p14="http://schemas.microsoft.com/office/powerpoint/2010/main" val="2450311204"/>
+        <p14:creationId xmlns:p14="http://schemas.microsoft.com/office/powerpoint/2010/main" val="2378136460"/>
       </p:ext>
     </p:extLst>
   </p:cSld>
@@ -6865,8 +6630,8 @@
           </a:p>
         </p:txBody>
       </p:sp>
-      <mc:AlternateContent xmlns:mc="http://schemas.openxmlformats.org/markup-compatibility/2006">
-        <mc:Choice xmlns:a14="http://schemas.microsoft.com/office/drawing/2010/main" Requires="a14">
+      <mc:AlternateContent xmlns:mc="http://schemas.openxmlformats.org/markup-compatibility/2006" xmlns:a14="http://schemas.microsoft.com/office/drawing/2010/main">
+        <mc:Choice Requires="a14">
           <p:sp>
             <p:nvSpPr>
               <p:cNvPr id="7" name="TextBox 6">
@@ -7355,7 +7120,7 @@
             </p:txBody>
           </p:sp>
         </mc:Choice>
-        <mc:Fallback>
+        <mc:Fallback xmlns="">
           <p:sp>
             <p:nvSpPr>
               <p:cNvPr id="7" name="TextBox 6">
@@ -7484,7 +7249,7 @@
           <p:cNvPr id="2" name="Title 1">
             <a:extLst>
               <a:ext uri="{FF2B5EF4-FFF2-40B4-BE49-F238E27FC236}">
-                <a16:creationId xmlns:a16="http://schemas.microsoft.com/office/drawing/2014/main" id="{4A407B3B-EE72-821F-0B1D-D3BA65D4AD2B}"/>
+                <a16:creationId xmlns:a16="http://schemas.microsoft.com/office/drawing/2014/main" id="{C607B642-90B5-3A5D-B803-AEED63E14F97}"/>
               </a:ext>
             </a:extLst>
           </p:cNvPr>
@@ -7495,14 +7260,19 @@
             <p:ph type="title"/>
           </p:nvPr>
         </p:nvSpPr>
-        <p:spPr/>
+        <p:spPr>
+          <a:xfrm>
+            <a:off x="1034143" y="105171"/>
+            <a:ext cx="10515600" cy="1325563"/>
+          </a:xfrm>
+        </p:spPr>
         <p:txBody>
           <a:bodyPr/>
           <a:lstStyle/>
           <a:p>
             <a:r>
               <a:rPr lang="en-US" dirty="0"/>
-              <a:t>LO(W)ESS fit: locally (weighted) estimated scatterplot smoothing</a:t>
+              <a:t>Parameter optimization</a:t>
             </a:r>
           </a:p>
         </p:txBody>
@@ -7512,7 +7282,7 @@
           <p:cNvPr id="3" name="Content Placeholder 2">
             <a:extLst>
               <a:ext uri="{FF2B5EF4-FFF2-40B4-BE49-F238E27FC236}">
-                <a16:creationId xmlns:a16="http://schemas.microsoft.com/office/drawing/2014/main" id="{A99A207F-16B7-76FF-FFF2-A1BB641A751A}"/>
+                <a16:creationId xmlns:a16="http://schemas.microsoft.com/office/drawing/2014/main" id="{A739CA0B-74C8-E9F9-9835-F15F2F80FF84}"/>
               </a:ext>
             </a:extLst>
           </p:cNvPr>
@@ -7523,118 +7293,274 @@
             <p:ph idx="1"/>
           </p:nvPr>
         </p:nvSpPr>
-        <p:spPr/>
+        <p:spPr>
+          <a:xfrm>
+            <a:off x="255105" y="1226472"/>
+            <a:ext cx="10515600" cy="4351338"/>
+          </a:xfrm>
+        </p:spPr>
         <p:txBody>
           <a:bodyPr/>
           <a:lstStyle/>
           <a:p>
             <a:r>
               <a:rPr lang="en-US" dirty="0"/>
-              <a:t>Immunity distributes across antigenic space in hills and valleys</a:t>
-            </a:r>
+              <a:t>Optimize parameters such that likelihood to obtain measured value with the given parameter set is maximized</a:t>
+            </a:r>
+          </a:p>
+          <a:p>
+            <a:r>
+              <a:rPr lang="en-US" dirty="0"/>
+              <a:t>Likelihood modelled as normal distribution with</a:t>
+            </a:r>
+          </a:p>
+          <a:p>
+            <a:pPr lvl="1"/>
+            <a:r>
+              <a:rPr lang="en-US" dirty="0"/>
+              <a:t>Mean = fitted value</a:t>
+            </a:r>
+          </a:p>
+          <a:p>
+            <a:pPr lvl="1"/>
+            <a:r>
+              <a:rPr lang="en-US" dirty="0"/>
+              <a:t>SD = user input (the wider, the </a:t>
+            </a:r>
+            <a:br>
+              <a:rPr lang="en-US" dirty="0"/>
+            </a:br>
+            <a:r>
+              <a:rPr lang="en-US" dirty="0"/>
+              <a:t>more likely large difference </a:t>
+            </a:r>
+            <a:br>
+              <a:rPr lang="en-US" dirty="0"/>
+            </a:br>
+            <a:r>
+              <a:rPr lang="en-US" dirty="0"/>
+              <a:t>between fitted and measured value)</a:t>
+            </a:r>
+          </a:p>
+          <a:p>
+            <a:pPr lvl="1"/>
+            <a:endParaRPr lang="en-US" dirty="0"/>
+          </a:p>
+          <a:p>
+            <a:pPr lvl="1"/>
+            <a:r>
+              <a:rPr lang="en-US" dirty="0">
+                <a:sym typeface="Wingdings" pitchFamily="2" charset="2"/>
+              </a:rPr>
+              <a:t> How likely is </a:t>
+            </a:r>
+            <a:r>
+              <a:rPr lang="en-US" dirty="0">
+                <a:solidFill>
+                  <a:srgbClr val="FF0000"/>
+                </a:solidFill>
+                <a:sym typeface="Wingdings" pitchFamily="2" charset="2"/>
+              </a:rPr>
+              <a:t>measuring the input </a:t>
+            </a:r>
+            <a:br>
+              <a:rPr lang="en-US" dirty="0">
+                <a:solidFill>
+                  <a:srgbClr val="FF0000"/>
+                </a:solidFill>
+                <a:sym typeface="Wingdings" pitchFamily="2" charset="2"/>
+              </a:rPr>
+            </a:br>
+            <a:r>
+              <a:rPr lang="en-US" dirty="0" err="1">
+                <a:solidFill>
+                  <a:srgbClr val="FF0000"/>
+                </a:solidFill>
+                <a:sym typeface="Wingdings" pitchFamily="2" charset="2"/>
+              </a:rPr>
+              <a:t>logtiter</a:t>
+            </a:r>
+            <a:r>
+              <a:rPr lang="en-US" dirty="0">
+                <a:sym typeface="Wingdings" pitchFamily="2" charset="2"/>
+              </a:rPr>
+              <a:t> when the </a:t>
+            </a:r>
+            <a:r>
+              <a:rPr lang="en-US" dirty="0">
+                <a:solidFill>
+                  <a:schemeClr val="tx2">
+                    <a:lumMod val="50000"/>
+                    <a:lumOff val="50000"/>
+                  </a:schemeClr>
+                </a:solidFill>
+                <a:sym typeface="Wingdings" pitchFamily="2" charset="2"/>
+              </a:rPr>
+              <a:t>expected value </a:t>
+            </a:r>
+            <a:br>
+              <a:rPr lang="en-US" dirty="0">
+                <a:solidFill>
+                  <a:schemeClr val="tx2">
+                    <a:lumMod val="50000"/>
+                    <a:lumOff val="50000"/>
+                  </a:schemeClr>
+                </a:solidFill>
+                <a:sym typeface="Wingdings" pitchFamily="2" charset="2"/>
+              </a:rPr>
+            </a:br>
+            <a:r>
+              <a:rPr lang="en-US" dirty="0">
+                <a:solidFill>
+                  <a:schemeClr val="tx2">
+                    <a:lumMod val="50000"/>
+                    <a:lumOff val="50000"/>
+                  </a:schemeClr>
+                </a:solidFill>
+                <a:sym typeface="Wingdings" pitchFamily="2" charset="2"/>
+              </a:rPr>
+              <a:t>is the fitted </a:t>
+            </a:r>
+            <a:r>
+              <a:rPr lang="en-US" dirty="0" err="1">
+                <a:solidFill>
+                  <a:schemeClr val="tx2">
+                    <a:lumMod val="50000"/>
+                    <a:lumOff val="50000"/>
+                  </a:schemeClr>
+                </a:solidFill>
+                <a:sym typeface="Wingdings" pitchFamily="2" charset="2"/>
+              </a:rPr>
+              <a:t>logtiter</a:t>
+            </a:r>
+            <a:r>
+              <a:rPr lang="en-US" dirty="0">
+                <a:sym typeface="Wingdings" pitchFamily="2" charset="2"/>
+              </a:rPr>
+              <a:t>?</a:t>
+            </a:r>
+            <a:endParaRPr lang="en-US" dirty="0"/>
           </a:p>
         </p:txBody>
       </p:sp>
       <p:pic>
         <p:nvPicPr>
-          <p:cNvPr id="5122" name="Picture 2">
-            <a:extLst>
-              <a:ext uri="{FF2B5EF4-FFF2-40B4-BE49-F238E27FC236}">
-                <a16:creationId xmlns:a16="http://schemas.microsoft.com/office/drawing/2014/main" id="{AAF3FCE3-9A3C-C3EB-14B8-F2E7BAFED45D}"/>
+          <p:cNvPr id="5" name="Picture 4">
+            <a:extLst>
+              <a:ext uri="{FF2B5EF4-FFF2-40B4-BE49-F238E27FC236}">
+                <a16:creationId xmlns:a16="http://schemas.microsoft.com/office/drawing/2014/main" id="{9E24B51C-906C-A3A7-C9D9-CA4665C1A9CF}"/>
               </a:ext>
             </a:extLst>
           </p:cNvPr>
           <p:cNvPicPr>
-            <a:picLocks noChangeAspect="1" noChangeArrowheads="1"/>
+            <a:picLocks noChangeAspect="1"/>
           </p:cNvPicPr>
           <p:nvPr/>
         </p:nvPicPr>
-        <p:blipFill rotWithShape="1">
-          <a:blip r:embed="rId2">
-            <a:extLst>
-              <a:ext uri="{28A0092B-C50C-407E-A947-70E740481C1C}">
-                <a14:useLocalDpi xmlns:a14="http://schemas.microsoft.com/office/drawing/2010/main" val="0"/>
-              </a:ext>
-            </a:extLst>
-          </a:blip>
-          <a:srcRect b="49683"/>
+        <p:blipFill>
+          <a:blip r:embed="rId2"/>
           <a:stretch>
             <a:fillRect/>
           </a:stretch>
         </p:blipFill>
-        <p:spPr bwMode="auto">
+        <p:spPr>
           <a:xfrm>
-            <a:off x="1306710" y="2726175"/>
-            <a:ext cx="4500563" cy="3450788"/>
+            <a:off x="6406873" y="2521601"/>
+            <a:ext cx="5530022" cy="4231228"/>
+          </a:xfrm>
+          <a:prstGeom prst="rect">
+            <a:avLst/>
+          </a:prstGeom>
+        </p:spPr>
+      </p:pic>
+      <p:sp>
+        <p:nvSpPr>
+          <p:cNvPr id="6" name="TextBox 5">
+            <a:extLst>
+              <a:ext uri="{FF2B5EF4-FFF2-40B4-BE49-F238E27FC236}">
+                <a16:creationId xmlns:a16="http://schemas.microsoft.com/office/drawing/2014/main" id="{38D48167-8CAB-503E-005A-5ACFD9045D96}"/>
+              </a:ext>
+            </a:extLst>
+          </p:cNvPr>
+          <p:cNvSpPr txBox="1"/>
+          <p:nvPr/>
+        </p:nvSpPr>
+        <p:spPr>
+          <a:xfrm>
+            <a:off x="10563949" y="5208478"/>
+            <a:ext cx="813043" cy="369332"/>
           </a:xfrm>
           <a:prstGeom prst="rect">
             <a:avLst/>
           </a:prstGeom>
           <a:noFill/>
-          <a:extLst>
-            <a:ext uri="{909E8E84-426E-40DD-AFC4-6F175D3DCCD1}">
-              <a14:hiddenFill xmlns:a14="http://schemas.microsoft.com/office/drawing/2010/main">
+        </p:spPr>
+        <p:txBody>
+          <a:bodyPr wrap="none" rtlCol="0">
+            <a:spAutoFit/>
+          </a:bodyPr>
+          <a:lstStyle/>
+          <a:p>
+            <a:r>
+              <a:rPr lang="en-US" dirty="0">
                 <a:solidFill>
-                  <a:srgbClr val="FFFFFF"/>
+                  <a:schemeClr val="bg1">
+                    <a:lumMod val="65000"/>
+                  </a:schemeClr>
                 </a:solidFill>
-              </a14:hiddenFill>
-            </a:ext>
-          </a:extLst>
-        </p:spPr>
-      </p:pic>
-      <p:pic>
-        <p:nvPicPr>
-          <p:cNvPr id="4" name="Picture 2">
-            <a:extLst>
-              <a:ext uri="{FF2B5EF4-FFF2-40B4-BE49-F238E27FC236}">
-                <a16:creationId xmlns:a16="http://schemas.microsoft.com/office/drawing/2014/main" id="{E2263491-3294-09B3-1085-03EB336FB7BD}"/>
-              </a:ext>
-            </a:extLst>
-          </p:cNvPr>
-          <p:cNvPicPr>
-            <a:picLocks noChangeAspect="1" noChangeArrowheads="1"/>
-          </p:cNvPicPr>
+              </a:rPr>
+              <a:t>SD = 2</a:t>
+            </a:r>
+          </a:p>
+        </p:txBody>
+      </p:sp>
+      <p:sp>
+        <p:nvSpPr>
+          <p:cNvPr id="7" name="TextBox 6">
+            <a:extLst>
+              <a:ext uri="{FF2B5EF4-FFF2-40B4-BE49-F238E27FC236}">
+                <a16:creationId xmlns:a16="http://schemas.microsoft.com/office/drawing/2014/main" id="{8AEF4501-B1C3-0A50-D8B3-618F2AC3DDE8}"/>
+              </a:ext>
+            </a:extLst>
+          </p:cNvPr>
+          <p:cNvSpPr txBox="1"/>
           <p:nvPr/>
-        </p:nvPicPr>
-        <p:blipFill rotWithShape="1">
-          <a:blip r:embed="rId2">
-            <a:extLst>
-              <a:ext uri="{28A0092B-C50C-407E-A947-70E740481C1C}">
-                <a14:useLocalDpi xmlns:a14="http://schemas.microsoft.com/office/drawing/2010/main" val="0"/>
-              </a:ext>
-            </a:extLst>
-          </a:blip>
-          <a:srcRect t="49683"/>
-          <a:stretch>
-            <a:fillRect/>
-          </a:stretch>
-        </p:blipFill>
-        <p:spPr bwMode="auto">
+        </p:nvSpPr>
+        <p:spPr>
           <a:xfrm>
-            <a:off x="6100915" y="2726175"/>
-            <a:ext cx="4500563" cy="3450788"/>
+            <a:off x="9338123" y="3886883"/>
+            <a:ext cx="813043" cy="369332"/>
           </a:xfrm>
           <a:prstGeom prst="rect">
             <a:avLst/>
           </a:prstGeom>
           <a:noFill/>
-          <a:extLst>
-            <a:ext uri="{909E8E84-426E-40DD-AFC4-6F175D3DCCD1}">
-              <a14:hiddenFill xmlns:a14="http://schemas.microsoft.com/office/drawing/2010/main">
+        </p:spPr>
+        <p:txBody>
+          <a:bodyPr wrap="none" rtlCol="0">
+            <a:spAutoFit/>
+          </a:bodyPr>
+          <a:lstStyle/>
+          <a:p>
+            <a:r>
+              <a:rPr lang="en-US" dirty="0">
                 <a:solidFill>
-                  <a:srgbClr val="FFFFFF"/>
+                  <a:schemeClr val="bg2">
+                    <a:lumMod val="50000"/>
+                  </a:schemeClr>
                 </a:solidFill>
-              </a14:hiddenFill>
-            </a:ext>
-          </a:extLst>
-        </p:spPr>
-      </p:pic>
-      <p:sp>
-        <p:nvSpPr>
-          <p:cNvPr id="5" name="TextBox 4">
-            <a:extLst>
-              <a:ext uri="{FF2B5EF4-FFF2-40B4-BE49-F238E27FC236}">
-                <a16:creationId xmlns:a16="http://schemas.microsoft.com/office/drawing/2014/main" id="{E61A2CE3-AA95-1EAC-2FE4-F819DBE5BE47}"/>
+              </a:rPr>
+              <a:t>SD = 1</a:t>
+            </a:r>
+          </a:p>
+        </p:txBody>
+      </p:sp>
+      <p:sp>
+        <p:nvSpPr>
+          <p:cNvPr id="8" name="TextBox 7">
+            <a:extLst>
+              <a:ext uri="{FF2B5EF4-FFF2-40B4-BE49-F238E27FC236}">
+                <a16:creationId xmlns:a16="http://schemas.microsoft.com/office/drawing/2014/main" id="{02DAFA0E-7D18-F465-B001-54075973F9B2}"/>
               </a:ext>
             </a:extLst>
           </p:cNvPr>
@@ -7643,8 +7569,8 @@
         </p:nvSpPr>
         <p:spPr>
           <a:xfrm>
-            <a:off x="4693495" y="6488668"/>
-            <a:ext cx="7315401" cy="369332"/>
+            <a:off x="7777895" y="2597075"/>
+            <a:ext cx="885627" cy="646331"/>
           </a:xfrm>
           <a:prstGeom prst="rect">
             <a:avLst/>
@@ -7658,24 +7584,103 @@
           <a:lstStyle/>
           <a:p>
             <a:r>
-              <a:rPr lang="en-US" dirty="0"/>
-              <a:t>Figure from Fonville et al. 2014 https://</a:t>
-            </a:r>
-            <a:r>
-              <a:rPr lang="en-US" dirty="0" err="1"/>
-              <a:t>doi.org</a:t>
-            </a:r>
-            <a:r>
-              <a:rPr lang="en-US" dirty="0"/>
-              <a:t>/10.1126/science.1256427</a:t>
-            </a:r>
+              <a:rPr lang="en-US" dirty="0">
+                <a:solidFill>
+                  <a:schemeClr val="tx2">
+                    <a:lumMod val="75000"/>
+                    <a:lumOff val="25000"/>
+                  </a:schemeClr>
+                </a:solidFill>
+              </a:rPr>
+              <a:t>Fitted </a:t>
+            </a:r>
+          </a:p>
+          <a:p>
+            <a:r>
+              <a:rPr lang="en-US" dirty="0" err="1">
+                <a:solidFill>
+                  <a:schemeClr val="tx2">
+                    <a:lumMod val="75000"/>
+                    <a:lumOff val="25000"/>
+                  </a:schemeClr>
+                </a:solidFill>
+              </a:rPr>
+              <a:t>logtiter</a:t>
+            </a:r>
+            <a:endParaRPr lang="en-US" dirty="0">
+              <a:solidFill>
+                <a:schemeClr val="tx2">
+                  <a:lumMod val="75000"/>
+                  <a:lumOff val="25000"/>
+                </a:schemeClr>
+              </a:solidFill>
+            </a:endParaRPr>
+          </a:p>
+        </p:txBody>
+      </p:sp>
+      <p:sp>
+        <p:nvSpPr>
+          <p:cNvPr id="9" name="TextBox 8">
+            <a:extLst>
+              <a:ext uri="{FF2B5EF4-FFF2-40B4-BE49-F238E27FC236}">
+                <a16:creationId xmlns:a16="http://schemas.microsoft.com/office/drawing/2014/main" id="{91BBC275-B5AA-D3C3-CF0D-5905DE3A6AFF}"/>
+              </a:ext>
+            </a:extLst>
+          </p:cNvPr>
+          <p:cNvSpPr txBox="1"/>
+          <p:nvPr/>
+        </p:nvSpPr>
+        <p:spPr>
+          <a:xfrm>
+            <a:off x="9218913" y="2597075"/>
+            <a:ext cx="1225079" cy="646331"/>
+          </a:xfrm>
+          <a:prstGeom prst="rect">
+            <a:avLst/>
+          </a:prstGeom>
+          <a:noFill/>
+        </p:spPr>
+        <p:txBody>
+          <a:bodyPr wrap="none" rtlCol="0">
+            <a:spAutoFit/>
+          </a:bodyPr>
+          <a:lstStyle/>
+          <a:p>
+            <a:r>
+              <a:rPr lang="en-US" dirty="0">
+                <a:solidFill>
+                  <a:srgbClr val="FF0000"/>
+                </a:solidFill>
+              </a:rPr>
+              <a:t>Measured </a:t>
+            </a:r>
+            <a:br>
+              <a:rPr lang="en-US" dirty="0">
+                <a:solidFill>
+                  <a:srgbClr val="FF0000"/>
+                </a:solidFill>
+              </a:rPr>
+            </a:br>
+            <a:r>
+              <a:rPr lang="en-US" dirty="0" err="1">
+                <a:solidFill>
+                  <a:srgbClr val="FF0000"/>
+                </a:solidFill>
+              </a:rPr>
+              <a:t>logtiter</a:t>
+            </a:r>
+            <a:endParaRPr lang="en-US" dirty="0">
+              <a:solidFill>
+                <a:srgbClr val="FF0000"/>
+              </a:solidFill>
+            </a:endParaRPr>
           </a:p>
         </p:txBody>
       </p:sp>
     </p:spTree>
     <p:extLst>
       <p:ext uri="{BB962C8B-B14F-4D97-AF65-F5344CB8AC3E}">
-        <p14:creationId xmlns:p14="http://schemas.microsoft.com/office/powerpoint/2010/main" val="1433763790"/>
+        <p14:creationId xmlns:p14="http://schemas.microsoft.com/office/powerpoint/2010/main" val="2450311204"/>
       </p:ext>
     </p:extLst>
   </p:cSld>

</xml_diff>